<commit_message>
Fix I'd pronunciation tip and remove WhatsApp task from I'd like microclase
Co-Authored-By: Claude Sonnet 5.5 <noreply@anthropic.com>
Claude-Session: https://claude.ai/code/session_01AK9pnJM83quWWTt8tkL4QY
</commit_message>
<xml_diff>
--- a/microclase-id-like.pptx
+++ b/microclase-id-like.pptx
@@ -653,7 +653,7 @@
               <a:rPr lang="en-US" dirty="0"/>
               <a:t>[5:20 a 6:00] CIERRE
 Hoy aprendiste a pedir con cortesía en un restaurante: cambia “I want” por “I’d like”. Recuerda la frase completa: “I’d like a coffee, please.”
-Tu práctica: graba un audio de 15 segundos pidiendo algo con “I’d like…” y envíalo al grupo de WhatsApp. Yo te doy retroalimentación. Hasta la próxima.</a:t>
+Hasta la próxima.</a:t>
             </a:r>
             <a:endParaRPr lang="en-US" dirty="0"/>
           </a:p>
@@ -834,7 +834,7 @@
               <a:t>[1:00 a 1:50] EXPRESIÓN
 El patrón es “I’d like” más lo que quieres pedir. Di: “I’d like a coffee, please.” Significa: “Me gustaría un café, por favor.”
 “I’d like” es la forma corta de “I would like”. Señala cada segmento en pantalla: “I’d like” es me gustaría; “a coffee” es lo que pides; “please” cierra con cortesía.
-Pronunciación: “I’d” suena como “aid”. Di “aid like”, sin separar las dos palabras.</a:t>
+Pronunciación: “I’d” suena como “ai-d”, la “ai” de “side” y sin la s. Di “ai-d like”, sin separar las dos palabras.</a:t>
             </a:r>
             <a:endParaRPr lang="en-US" dirty="0"/>
           </a:p>
@@ -1017,7 +1017,7 @@
 1. “I’d like a coffee, please.” (Pausa de 4 segundos.)
 2. “I’d like a tea, please.” (Pausa de 4 segundos.)
 3. “I’d like a chicken sandwich, please.” (Pausa de 4 segundos.)
-Cuida el sonido “aid like” y el “please” al final.</a:t>
+Cuida el sonido “ai-d like” y el “please” al final.</a:t>
             </a:r>
             <a:endParaRPr lang="en-US" dirty="0"/>
           </a:p>
@@ -3234,8 +3234,8 @@
         </p:nvSpPr>
         <p:spPr>
           <a:xfrm>
-            <a:off x="548640" y="1874520"/>
-            <a:ext cx="7863840" cy="1097280"/>
+            <a:off x="548640" y="1874519"/>
+            <a:ext cx="7863840" cy="1737360"/>
           </a:xfrm>
           <a:prstGeom prst="roundRect">
             <a:avLst>
@@ -3261,8 +3261,8 @@
         </p:nvSpPr>
         <p:spPr>
           <a:xfrm>
-            <a:off x="868680" y="1874520"/>
-            <a:ext cx="7223760" cy="1097280"/>
+            <a:off x="868680" y="1874519"/>
+            <a:ext cx="7223760" cy="1737360"/>
           </a:xfrm>
           <a:prstGeom prst="rect">
             <a:avLst/>
@@ -3300,8 +3300,8 @@
         </p:nvSpPr>
         <p:spPr>
           <a:xfrm>
-            <a:off x="548640" y="3154680"/>
-            <a:ext cx="7863840" cy="868680"/>
+            <a:off x="548640" y="3840480"/>
+            <a:ext cx="7863840" cy="1691640"/>
           </a:xfrm>
           <a:prstGeom prst="roundRect">
             <a:avLst>
@@ -3327,8 +3327,8 @@
         </p:nvSpPr>
         <p:spPr>
           <a:xfrm>
-            <a:off x="868680" y="3154680"/>
-            <a:ext cx="7223760" cy="868680"/>
+            <a:off x="868680" y="3840480"/>
+            <a:ext cx="7223760" cy="1691640"/>
           </a:xfrm>
           <a:prstGeom prst="rect">
             <a:avLst/>
@@ -3355,119 +3355,6 @@
               <a:t>I want  →  I’d like</a:t>
             </a:r>
             <a:endParaRPr lang="en-US" sz="2800" dirty="0"/>
-          </a:p>
-        </p:txBody>
-      </p:sp>
-      <p:sp>
-        <p:nvSpPr>
-          <p:cNvPr id="11" name="Tarea"/>
-          <p:cNvSpPr/>
-          <p:nvPr/>
-        </p:nvSpPr>
-        <p:spPr>
-          <a:xfrm>
-            <a:off x="548640" y="4206240"/>
-            <a:ext cx="7863840" cy="2103120"/>
-          </a:xfrm>
-          <a:prstGeom prst="roundRect">
-            <a:avLst>
-              <a:gd name="adj" fmla="val 5217"/>
-            </a:avLst>
-          </a:prstGeom>
-          <a:solidFill>
-            <a:schemeClr val="bg1"/>
-          </a:solidFill>
-          <a:ln w="19050">
-            <a:solidFill>
-              <a:schemeClr val="tx1"/>
-            </a:solidFill>
-            <a:prstDash val="solid"/>
-          </a:ln>
-        </p:spPr>
-      </p:sp>
-      <p:pic>
-        <p:nvPicPr>
-          <p:cNvPr id="12" name="Ícono micrófono" descr="Micrófono">    </p:cNvPr>
-          <p:cNvPicPr>
-            <a:picLocks noChangeAspect="1"/>
-          </p:cNvPicPr>
-          <p:nvPr/>
-        </p:nvPicPr>
-        <p:blipFill>
-          <a:blip r:embed="rId1"/>
-          <a:stretch>
-            <a:fillRect/>
-          </a:stretch>
-        </p:blipFill>
-        <p:spPr>
-          <a:xfrm>
-            <a:off x="868680" y="4434840"/>
-            <a:ext cx="640080" cy="640080"/>
-          </a:xfrm>
-          <a:prstGeom prst="rect">
-            <a:avLst/>
-          </a:prstGeom>
-        </p:spPr>
-      </p:pic>
-      <p:sp>
-        <p:nvSpPr>
-          <p:cNvPr id="13" name="Texto tarea"/>
-          <p:cNvSpPr txBox="1"/>
-          <p:nvPr/>
-        </p:nvSpPr>
-        <p:spPr>
-          <a:xfrm>
-            <a:off x="1783080" y="4206240"/>
-            <a:ext cx="6400800" cy="2103120"/>
-          </a:xfrm>
-          <a:prstGeom prst="rect">
-            <a:avLst/>
-          </a:prstGeom>
-          <a:noFill/>
-          <a:ln/>
-        </p:spPr>
-        <p:txBody>
-          <a:bodyPr wrap="square" lIns="0" tIns="0" rIns="0" bIns="0" rtlCol="0" anchor="ctr"/>
-          <a:lstStyle/>
-          <a:p>
-            <a:pPr indent="0" marL="0">
-              <a:spcAft>
-                <a:spcPts val="400"/>
-              </a:spcAft>
-              <a:buNone/>
-            </a:pPr>
-            <a:r>
-              <a:rPr lang="en-US" sz="2400" dirty="0">
-                <a:solidFill>
-                  <a:schemeClr val="tx1"/>
-                </a:solidFill>
-                <a:latin typeface="Work Sans" pitchFamily="34" charset="0"/>
-                <a:ea typeface="Work Sans" pitchFamily="34" charset="-122"/>
-                <a:cs typeface="Work Sans" pitchFamily="34" charset="-120"/>
-              </a:rPr>
-              <a:t>Tu práctica:</a:t>
-            </a:r>
-            <a:endParaRPr lang="en-US" sz="2400" dirty="0"/>
-          </a:p>
-          <a:p>
-            <a:pPr indent="0" marL="0">
-              <a:spcAft>
-                <a:spcPts val="400"/>
-              </a:spcAft>
-              <a:buNone/>
-            </a:pPr>
-            <a:r>
-              <a:rPr lang="en-US" sz="2400" b="1" dirty="0">
-                <a:solidFill>
-                  <a:schemeClr val="tx1"/>
-                </a:solidFill>
-                <a:latin typeface="Work Sans" pitchFamily="34" charset="0"/>
-                <a:ea typeface="Work Sans" pitchFamily="34" charset="-122"/>
-                <a:cs typeface="Work Sans" pitchFamily="34" charset="-120"/>
-              </a:rPr>
-              <a:t>Envía un audio de 15 segundos al grupo de WhatsApp pidiendo algo con “I’d like…”. Mercedes te responde.</a:t>
-            </a:r>
-            <a:endParaRPr lang="en-US" sz="2400" dirty="0"/>
           </a:p>
         </p:txBody>
       </p:sp>

</xml_diff>